<commit_message>
docs: update presentation file
</commit_message>
<xml_diff>
--- a/Document_Action_Extractor_Presentation.pptx
+++ b/Document_Action_Extractor_Presentation.pptx
@@ -5,17 +5,17 @@
     <p:sldMasterId id="2147483648" r:id="rId1"/>
   </p:sldMasterIdLst>
   <p:sldIdLst>
-    <p:sldId id="256" r:id="rId7"/>
-    <p:sldId id="257" r:id="rId8"/>
-    <p:sldId id="258" r:id="rId9"/>
-    <p:sldId id="259" r:id="rId10"/>
-    <p:sldId id="260" r:id="rId11"/>
-    <p:sldId id="261" r:id="rId12"/>
-    <p:sldId id="262" r:id="rId13"/>
-    <p:sldId id="263" r:id="rId14"/>
-    <p:sldId id="264" r:id="rId15"/>
+    <p:sldId id="256" r:id="rId2"/>
+    <p:sldId id="257" r:id="rId3"/>
+    <p:sldId id="258" r:id="rId4"/>
+    <p:sldId id="259" r:id="rId5"/>
+    <p:sldId id="260" r:id="rId6"/>
+    <p:sldId id="261" r:id="rId7"/>
+    <p:sldId id="262" r:id="rId8"/>
+    <p:sldId id="263" r:id="rId9"/>
+    <p:sldId id="264" r:id="rId10"/>
   </p:sldIdLst>
-  <p:sldSz cx="12191695" cy="6858000" type="screen4x3"/>
+  <p:sldSz cx="12192000" cy="6858000"/>
   <p:notesSz cx="6858000" cy="9144000"/>
   <p:defaultTextStyle>
     <a:defPPr>
@@ -112,6 +112,22 @@
       </a:defRPr>
     </a:lvl9pPr>
   </p:defaultTextStyle>
+  <p:extLst>
+    <p:ext uri="{EFAFB233-063F-42B5-8137-9DF3F51BA10A}">
+      <p15:sldGuideLst xmlns:p15="http://schemas.microsoft.com/office/powerpoint/2012/main">
+        <p15:guide id="1" orient="horz" pos="2160">
+          <p15:clr>
+            <a:srgbClr val="A4A3A4"/>
+          </p15:clr>
+        </p15:guide>
+        <p15:guide id="2" pos="2880">
+          <p15:clr>
+            <a:srgbClr val="A4A3A4"/>
+          </p15:clr>
+        </p15:guide>
+      </p15:sldGuideLst>
+    </p:ext>
+  </p:extLst>
 </p:presentation>
 </file>
 
@@ -153,10 +169,9 @@
           <a:lstStyle/>
           <a:p>
             <a:r>
-              <a:rPr lang="en-US" smtClean="0"/>
+              <a:rPr lang="en-US"/>
               <a:t>Click to edit Master title style</a:t>
             </a:r>
-            <a:endParaRPr lang="en-US"/>
           </a:p>
         </p:txBody>
       </p:sp>
@@ -272,10 +287,9 @@
           </a:lstStyle>
           <a:p>
             <a:r>
-              <a:rPr lang="en-US" smtClean="0"/>
+              <a:rPr lang="en-US"/>
               <a:t>Click to edit Master subtitle style</a:t>
             </a:r>
-            <a:endParaRPr lang="en-US"/>
           </a:p>
         </p:txBody>
       </p:sp>
@@ -296,7 +310,7 @@
           <a:p>
             <a:fld id="{5BCAD085-E8A6-8845-BD4E-CB4CCA059FC4}" type="datetimeFigureOut">
               <a:rPr lang="en-US" smtClean="0"/>
-              <a:t>1/27/13</a:t>
+              <a:t>9/29/2026</a:t>
             </a:fld>
             <a:endParaRPr lang="en-US"/>
           </a:p>
@@ -390,10 +404,9 @@
           <a:lstStyle/>
           <a:p>
             <a:r>
-              <a:rPr lang="en-US" smtClean="0"/>
+              <a:rPr lang="en-US"/>
               <a:t>Click to edit Master title style</a:t>
             </a:r>
-            <a:endParaRPr lang="en-US"/>
           </a:p>
         </p:txBody>
       </p:sp>
@@ -414,38 +427,37 @@
           <a:p>
             <a:pPr lvl="0"/>
             <a:r>
-              <a:rPr lang="en-US" smtClean="0"/>
+              <a:rPr lang="en-US"/>
               <a:t>Click to edit Master text styles</a:t>
             </a:r>
           </a:p>
           <a:p>
             <a:pPr lvl="1"/>
             <a:r>
-              <a:rPr lang="en-US" smtClean="0"/>
+              <a:rPr lang="en-US"/>
               <a:t>Second level</a:t>
             </a:r>
           </a:p>
           <a:p>
             <a:pPr lvl="2"/>
             <a:r>
-              <a:rPr lang="en-US" smtClean="0"/>
+              <a:rPr lang="en-US"/>
               <a:t>Third level</a:t>
             </a:r>
           </a:p>
           <a:p>
             <a:pPr lvl="3"/>
             <a:r>
-              <a:rPr lang="en-US" smtClean="0"/>
+              <a:rPr lang="en-US"/>
               <a:t>Fourth level</a:t>
             </a:r>
           </a:p>
           <a:p>
             <a:pPr lvl="4"/>
             <a:r>
-              <a:rPr lang="en-US" smtClean="0"/>
+              <a:rPr lang="en-US"/>
               <a:t>Fifth level</a:t>
             </a:r>
-            <a:endParaRPr lang="en-US"/>
           </a:p>
         </p:txBody>
       </p:sp>
@@ -466,7 +478,7 @@
           <a:p>
             <a:fld id="{5BCAD085-E8A6-8845-BD4E-CB4CCA059FC4}" type="datetimeFigureOut">
               <a:rPr lang="en-US" smtClean="0"/>
-              <a:t>1/27/13</a:t>
+              <a:t>9/29/2026</a:t>
             </a:fld>
             <a:endParaRPr lang="en-US"/>
           </a:p>
@@ -565,10 +577,9 @@
           <a:lstStyle/>
           <a:p>
             <a:r>
-              <a:rPr lang="en-US" smtClean="0"/>
+              <a:rPr lang="en-US"/>
               <a:t>Click to edit Master title style</a:t>
             </a:r>
-            <a:endParaRPr lang="en-US"/>
           </a:p>
         </p:txBody>
       </p:sp>
@@ -594,38 +605,37 @@
           <a:p>
             <a:pPr lvl="0"/>
             <a:r>
-              <a:rPr lang="en-US" smtClean="0"/>
+              <a:rPr lang="en-US"/>
               <a:t>Click to edit Master text styles</a:t>
             </a:r>
           </a:p>
           <a:p>
             <a:pPr lvl="1"/>
             <a:r>
-              <a:rPr lang="en-US" smtClean="0"/>
+              <a:rPr lang="en-US"/>
               <a:t>Second level</a:t>
             </a:r>
           </a:p>
           <a:p>
             <a:pPr lvl="2"/>
             <a:r>
-              <a:rPr lang="en-US" smtClean="0"/>
+              <a:rPr lang="en-US"/>
               <a:t>Third level</a:t>
             </a:r>
           </a:p>
           <a:p>
             <a:pPr lvl="3"/>
             <a:r>
-              <a:rPr lang="en-US" smtClean="0"/>
+              <a:rPr lang="en-US"/>
               <a:t>Fourth level</a:t>
             </a:r>
           </a:p>
           <a:p>
             <a:pPr lvl="4"/>
             <a:r>
-              <a:rPr lang="en-US" smtClean="0"/>
+              <a:rPr lang="en-US"/>
               <a:t>Fifth level</a:t>
             </a:r>
-            <a:endParaRPr lang="en-US"/>
           </a:p>
         </p:txBody>
       </p:sp>
@@ -646,7 +656,7 @@
           <a:p>
             <a:fld id="{5BCAD085-E8A6-8845-BD4E-CB4CCA059FC4}" type="datetimeFigureOut">
               <a:rPr lang="en-US" smtClean="0"/>
-              <a:t>1/27/13</a:t>
+              <a:t>9/29/2026</a:t>
             </a:fld>
             <a:endParaRPr lang="en-US"/>
           </a:p>
@@ -740,10 +750,9 @@
           <a:lstStyle/>
           <a:p>
             <a:r>
-              <a:rPr lang="en-US" smtClean="0"/>
+              <a:rPr lang="en-US"/>
               <a:t>Click to edit Master title style</a:t>
             </a:r>
-            <a:endParaRPr lang="en-US"/>
           </a:p>
         </p:txBody>
       </p:sp>
@@ -764,38 +773,37 @@
           <a:p>
             <a:pPr lvl="0"/>
             <a:r>
-              <a:rPr lang="en-US" smtClean="0"/>
+              <a:rPr lang="en-US"/>
               <a:t>Click to edit Master text styles</a:t>
             </a:r>
           </a:p>
           <a:p>
             <a:pPr lvl="1"/>
             <a:r>
-              <a:rPr lang="en-US" smtClean="0"/>
+              <a:rPr lang="en-US"/>
               <a:t>Second level</a:t>
             </a:r>
           </a:p>
           <a:p>
             <a:pPr lvl="2"/>
             <a:r>
-              <a:rPr lang="en-US" smtClean="0"/>
+              <a:rPr lang="en-US"/>
               <a:t>Third level</a:t>
             </a:r>
           </a:p>
           <a:p>
             <a:pPr lvl="3"/>
             <a:r>
-              <a:rPr lang="en-US" smtClean="0"/>
+              <a:rPr lang="en-US"/>
               <a:t>Fourth level</a:t>
             </a:r>
           </a:p>
           <a:p>
             <a:pPr lvl="4"/>
             <a:r>
-              <a:rPr lang="en-US" smtClean="0"/>
+              <a:rPr lang="en-US"/>
               <a:t>Fifth level</a:t>
             </a:r>
-            <a:endParaRPr lang="en-US"/>
           </a:p>
         </p:txBody>
       </p:sp>
@@ -816,7 +824,7 @@
           <a:p>
             <a:fld id="{5BCAD085-E8A6-8845-BD4E-CB4CCA059FC4}" type="datetimeFigureOut">
               <a:rPr lang="en-US" smtClean="0"/>
-              <a:t>1/27/13</a:t>
+              <a:t>9/29/2026</a:t>
             </a:fld>
             <a:endParaRPr lang="en-US"/>
           </a:p>
@@ -919,10 +927,9 @@
           </a:lstStyle>
           <a:p>
             <a:r>
-              <a:rPr lang="en-US" smtClean="0"/>
+              <a:rPr lang="en-US"/>
               <a:t>Click to edit Master title style</a:t>
             </a:r>
-            <a:endParaRPr lang="en-US"/>
           </a:p>
         </p:txBody>
       </p:sp>
@@ -1039,7 +1046,7 @@
           <a:p>
             <a:pPr lvl="0"/>
             <a:r>
-              <a:rPr lang="en-US" smtClean="0"/>
+              <a:rPr lang="en-US"/>
               <a:t>Click to edit Master text styles</a:t>
             </a:r>
           </a:p>
@@ -1062,7 +1069,7 @@
           <a:p>
             <a:fld id="{5BCAD085-E8A6-8845-BD4E-CB4CCA059FC4}" type="datetimeFigureOut">
               <a:rPr lang="en-US" smtClean="0"/>
-              <a:t>1/27/13</a:t>
+              <a:t>9/29/2026</a:t>
             </a:fld>
             <a:endParaRPr lang="en-US"/>
           </a:p>
@@ -1156,10 +1163,9 @@
           <a:lstStyle/>
           <a:p>
             <a:r>
-              <a:rPr lang="en-US" smtClean="0"/>
+              <a:rPr lang="en-US"/>
               <a:t>Click to edit Master title style</a:t>
             </a:r>
-            <a:endParaRPr lang="en-US"/>
           </a:p>
         </p:txBody>
       </p:sp>
@@ -1213,38 +1219,37 @@
           <a:p>
             <a:pPr lvl="0"/>
             <a:r>
-              <a:rPr lang="en-US" smtClean="0"/>
+              <a:rPr lang="en-US"/>
               <a:t>Click to edit Master text styles</a:t>
             </a:r>
           </a:p>
           <a:p>
             <a:pPr lvl="1"/>
             <a:r>
-              <a:rPr lang="en-US" smtClean="0"/>
+              <a:rPr lang="en-US"/>
               <a:t>Second level</a:t>
             </a:r>
           </a:p>
           <a:p>
             <a:pPr lvl="2"/>
             <a:r>
-              <a:rPr lang="en-US" smtClean="0"/>
+              <a:rPr lang="en-US"/>
               <a:t>Third level</a:t>
             </a:r>
           </a:p>
           <a:p>
             <a:pPr lvl="3"/>
             <a:r>
-              <a:rPr lang="en-US" smtClean="0"/>
+              <a:rPr lang="en-US"/>
               <a:t>Fourth level</a:t>
             </a:r>
           </a:p>
           <a:p>
             <a:pPr lvl="4"/>
             <a:r>
-              <a:rPr lang="en-US" smtClean="0"/>
+              <a:rPr lang="en-US"/>
               <a:t>Fifth level</a:t>
             </a:r>
-            <a:endParaRPr lang="en-US"/>
           </a:p>
         </p:txBody>
       </p:sp>
@@ -1298,38 +1303,37 @@
           <a:p>
             <a:pPr lvl="0"/>
             <a:r>
-              <a:rPr lang="en-US" smtClean="0"/>
+              <a:rPr lang="en-US"/>
               <a:t>Click to edit Master text styles</a:t>
             </a:r>
           </a:p>
           <a:p>
             <a:pPr lvl="1"/>
             <a:r>
-              <a:rPr lang="en-US" smtClean="0"/>
+              <a:rPr lang="en-US"/>
               <a:t>Second level</a:t>
             </a:r>
           </a:p>
           <a:p>
             <a:pPr lvl="2"/>
             <a:r>
-              <a:rPr lang="en-US" smtClean="0"/>
+              <a:rPr lang="en-US"/>
               <a:t>Third level</a:t>
             </a:r>
           </a:p>
           <a:p>
             <a:pPr lvl="3"/>
             <a:r>
-              <a:rPr lang="en-US" smtClean="0"/>
+              <a:rPr lang="en-US"/>
               <a:t>Fourth level</a:t>
             </a:r>
           </a:p>
           <a:p>
             <a:pPr lvl="4"/>
             <a:r>
-              <a:rPr lang="en-US" smtClean="0"/>
+              <a:rPr lang="en-US"/>
               <a:t>Fifth level</a:t>
             </a:r>
-            <a:endParaRPr lang="en-US"/>
           </a:p>
         </p:txBody>
       </p:sp>
@@ -1350,7 +1354,7 @@
           <a:p>
             <a:fld id="{5BCAD085-E8A6-8845-BD4E-CB4CCA059FC4}" type="datetimeFigureOut">
               <a:rPr lang="en-US" smtClean="0"/>
-              <a:t>1/27/13</a:t>
+              <a:t>9/29/2026</a:t>
             </a:fld>
             <a:endParaRPr lang="en-US"/>
           </a:p>
@@ -1448,10 +1452,9 @@
           </a:lstStyle>
           <a:p>
             <a:r>
-              <a:rPr lang="en-US" smtClean="0"/>
+              <a:rPr lang="en-US"/>
               <a:t>Click to edit Master title style</a:t>
             </a:r>
-            <a:endParaRPr lang="en-US"/>
           </a:p>
         </p:txBody>
       </p:sp>
@@ -1514,7 +1517,7 @@
           <a:p>
             <a:pPr lvl="0"/>
             <a:r>
-              <a:rPr lang="en-US" smtClean="0"/>
+              <a:rPr lang="en-US"/>
               <a:t>Click to edit Master text styles</a:t>
             </a:r>
           </a:p>
@@ -1570,38 +1573,37 @@
           <a:p>
             <a:pPr lvl="0"/>
             <a:r>
-              <a:rPr lang="en-US" smtClean="0"/>
+              <a:rPr lang="en-US"/>
               <a:t>Click to edit Master text styles</a:t>
             </a:r>
           </a:p>
           <a:p>
             <a:pPr lvl="1"/>
             <a:r>
-              <a:rPr lang="en-US" smtClean="0"/>
+              <a:rPr lang="en-US"/>
               <a:t>Second level</a:t>
             </a:r>
           </a:p>
           <a:p>
             <a:pPr lvl="2"/>
             <a:r>
-              <a:rPr lang="en-US" smtClean="0"/>
+              <a:rPr lang="en-US"/>
               <a:t>Third level</a:t>
             </a:r>
           </a:p>
           <a:p>
             <a:pPr lvl="3"/>
             <a:r>
-              <a:rPr lang="en-US" smtClean="0"/>
+              <a:rPr lang="en-US"/>
               <a:t>Fourth level</a:t>
             </a:r>
           </a:p>
           <a:p>
             <a:pPr lvl="4"/>
             <a:r>
-              <a:rPr lang="en-US" smtClean="0"/>
+              <a:rPr lang="en-US"/>
               <a:t>Fifth level</a:t>
             </a:r>
-            <a:endParaRPr lang="en-US"/>
           </a:p>
         </p:txBody>
       </p:sp>
@@ -1664,7 +1666,7 @@
           <a:p>
             <a:pPr lvl="0"/>
             <a:r>
-              <a:rPr lang="en-US" smtClean="0"/>
+              <a:rPr lang="en-US"/>
               <a:t>Click to edit Master text styles</a:t>
             </a:r>
           </a:p>
@@ -1720,38 +1722,37 @@
           <a:p>
             <a:pPr lvl="0"/>
             <a:r>
-              <a:rPr lang="en-US" smtClean="0"/>
+              <a:rPr lang="en-US"/>
               <a:t>Click to edit Master text styles</a:t>
             </a:r>
           </a:p>
           <a:p>
             <a:pPr lvl="1"/>
             <a:r>
-              <a:rPr lang="en-US" smtClean="0"/>
+              <a:rPr lang="en-US"/>
               <a:t>Second level</a:t>
             </a:r>
           </a:p>
           <a:p>
             <a:pPr lvl="2"/>
             <a:r>
-              <a:rPr lang="en-US" smtClean="0"/>
+              <a:rPr lang="en-US"/>
               <a:t>Third level</a:t>
             </a:r>
           </a:p>
           <a:p>
             <a:pPr lvl="3"/>
             <a:r>
-              <a:rPr lang="en-US" smtClean="0"/>
+              <a:rPr lang="en-US"/>
               <a:t>Fourth level</a:t>
             </a:r>
           </a:p>
           <a:p>
             <a:pPr lvl="4"/>
             <a:r>
-              <a:rPr lang="en-US" smtClean="0"/>
+              <a:rPr lang="en-US"/>
               <a:t>Fifth level</a:t>
             </a:r>
-            <a:endParaRPr lang="en-US"/>
           </a:p>
         </p:txBody>
       </p:sp>
@@ -1772,7 +1773,7 @@
           <a:p>
             <a:fld id="{5BCAD085-E8A6-8845-BD4E-CB4CCA059FC4}" type="datetimeFigureOut">
               <a:rPr lang="en-US" smtClean="0"/>
-              <a:t>1/27/13</a:t>
+              <a:t>9/29/2026</a:t>
             </a:fld>
             <a:endParaRPr lang="en-US"/>
           </a:p>
@@ -1866,10 +1867,9 @@
           <a:lstStyle/>
           <a:p>
             <a:r>
-              <a:rPr lang="en-US" smtClean="0"/>
+              <a:rPr lang="en-US"/>
               <a:t>Click to edit Master title style</a:t>
             </a:r>
-            <a:endParaRPr lang="en-US"/>
           </a:p>
         </p:txBody>
       </p:sp>
@@ -1890,7 +1890,7 @@
           <a:p>
             <a:fld id="{5BCAD085-E8A6-8845-BD4E-CB4CCA059FC4}" type="datetimeFigureOut">
               <a:rPr lang="en-US" smtClean="0"/>
-              <a:t>1/27/13</a:t>
+              <a:t>9/29/2026</a:t>
             </a:fld>
             <a:endParaRPr lang="en-US"/>
           </a:p>
@@ -1985,7 +1985,7 @@
           <a:p>
             <a:fld id="{5BCAD085-E8A6-8845-BD4E-CB4CCA059FC4}" type="datetimeFigureOut">
               <a:rPr lang="en-US" smtClean="0"/>
-              <a:t>1/27/13</a:t>
+              <a:t>9/29/2026</a:t>
             </a:fld>
             <a:endParaRPr lang="en-US"/>
           </a:p>
@@ -2088,10 +2088,9 @@
           </a:lstStyle>
           <a:p>
             <a:r>
-              <a:rPr lang="en-US" smtClean="0"/>
+              <a:rPr lang="en-US"/>
               <a:t>Click to edit Master title style</a:t>
             </a:r>
-            <a:endParaRPr lang="en-US"/>
           </a:p>
         </p:txBody>
       </p:sp>
@@ -2145,38 +2144,37 @@
           <a:p>
             <a:pPr lvl="0"/>
             <a:r>
-              <a:rPr lang="en-US" smtClean="0"/>
+              <a:rPr lang="en-US"/>
               <a:t>Click to edit Master text styles</a:t>
             </a:r>
           </a:p>
           <a:p>
             <a:pPr lvl="1"/>
             <a:r>
-              <a:rPr lang="en-US" smtClean="0"/>
+              <a:rPr lang="en-US"/>
               <a:t>Second level</a:t>
             </a:r>
           </a:p>
           <a:p>
             <a:pPr lvl="2"/>
             <a:r>
-              <a:rPr lang="en-US" smtClean="0"/>
+              <a:rPr lang="en-US"/>
               <a:t>Third level</a:t>
             </a:r>
           </a:p>
           <a:p>
             <a:pPr lvl="3"/>
             <a:r>
-              <a:rPr lang="en-US" smtClean="0"/>
+              <a:rPr lang="en-US"/>
               <a:t>Fourth level</a:t>
             </a:r>
           </a:p>
           <a:p>
             <a:pPr lvl="4"/>
             <a:r>
-              <a:rPr lang="en-US" smtClean="0"/>
+              <a:rPr lang="en-US"/>
               <a:t>Fifth level</a:t>
             </a:r>
-            <a:endParaRPr lang="en-US"/>
           </a:p>
         </p:txBody>
       </p:sp>
@@ -2239,7 +2237,7 @@
           <a:p>
             <a:pPr lvl="0"/>
             <a:r>
-              <a:rPr lang="en-US" smtClean="0"/>
+              <a:rPr lang="en-US"/>
               <a:t>Click to edit Master text styles</a:t>
             </a:r>
           </a:p>
@@ -2262,7 +2260,7 @@
           <a:p>
             <a:fld id="{5BCAD085-E8A6-8845-BD4E-CB4CCA059FC4}" type="datetimeFigureOut">
               <a:rPr lang="en-US" smtClean="0"/>
-              <a:t>1/27/13</a:t>
+              <a:t>9/29/2026</a:t>
             </a:fld>
             <a:endParaRPr lang="en-US"/>
           </a:p>
@@ -2365,10 +2363,9 @@
           </a:lstStyle>
           <a:p>
             <a:r>
-              <a:rPr lang="en-US" smtClean="0"/>
+              <a:rPr lang="en-US"/>
               <a:t>Click to edit Master title style</a:t>
             </a:r>
-            <a:endParaRPr lang="en-US"/>
           </a:p>
         </p:txBody>
       </p:sp>
@@ -2492,7 +2489,7 @@
           <a:p>
             <a:pPr lvl="0"/>
             <a:r>
-              <a:rPr lang="en-US" smtClean="0"/>
+              <a:rPr lang="en-US"/>
               <a:t>Click to edit Master text styles</a:t>
             </a:r>
           </a:p>
@@ -2515,7 +2512,7 @@
           <a:p>
             <a:fld id="{5BCAD085-E8A6-8845-BD4E-CB4CCA059FC4}" type="datetimeFigureOut">
               <a:rPr lang="en-US" smtClean="0"/>
-              <a:t>1/27/13</a:t>
+              <a:t>9/29/2026</a:t>
             </a:fld>
             <a:endParaRPr lang="en-US"/>
           </a:p>
@@ -2624,10 +2621,9 @@
           <a:lstStyle/>
           <a:p>
             <a:r>
-              <a:rPr lang="en-US" smtClean="0"/>
+              <a:rPr lang="en-US"/>
               <a:t>Click to edit Master title style</a:t>
             </a:r>
-            <a:endParaRPr lang="en-US"/>
           </a:p>
         </p:txBody>
       </p:sp>
@@ -2658,38 +2654,37 @@
           <a:p>
             <a:pPr lvl="0"/>
             <a:r>
-              <a:rPr lang="en-US" smtClean="0"/>
+              <a:rPr lang="en-US"/>
               <a:t>Click to edit Master text styles</a:t>
             </a:r>
           </a:p>
           <a:p>
             <a:pPr lvl="1"/>
             <a:r>
-              <a:rPr lang="en-US" smtClean="0"/>
+              <a:rPr lang="en-US"/>
               <a:t>Second level</a:t>
             </a:r>
           </a:p>
           <a:p>
             <a:pPr lvl="2"/>
             <a:r>
-              <a:rPr lang="en-US" smtClean="0"/>
+              <a:rPr lang="en-US"/>
               <a:t>Third level</a:t>
             </a:r>
           </a:p>
           <a:p>
             <a:pPr lvl="3"/>
             <a:r>
-              <a:rPr lang="en-US" smtClean="0"/>
+              <a:rPr lang="en-US"/>
               <a:t>Fourth level</a:t>
             </a:r>
           </a:p>
           <a:p>
             <a:pPr lvl="4"/>
             <a:r>
-              <a:rPr lang="en-US" smtClean="0"/>
+              <a:rPr lang="en-US"/>
               <a:t>Fifth level</a:t>
             </a:r>
-            <a:endParaRPr lang="en-US"/>
           </a:p>
         </p:txBody>
       </p:sp>
@@ -2728,7 +2723,7 @@
           <a:p>
             <a:fld id="{5BCAD085-E8A6-8845-BD4E-CB4CCA059FC4}" type="datetimeFigureOut">
               <a:rPr lang="en-US" smtClean="0"/>
-              <a:t>1/27/13</a:t>
+              <a:t>9/29/2026</a:t>
             </a:fld>
             <a:endParaRPr lang="en-US"/>
           </a:p>
@@ -3087,7 +3082,7 @@
 </file>
 
 <file path=ppt/slides/slide1.xml><?xml version="1.0" encoding="utf-8"?>
-<p:sld xmlns:a="http://schemas.openxmlformats.org/drawingml/2006/main" xmlns:p="http://schemas.openxmlformats.org/presentationml/2006/main" xmlns:r="http://schemas.openxmlformats.org/officeDocument/2006/relationships">
+<p:sld xmlns:a="http://schemas.openxmlformats.org/drawingml/2006/main" xmlns:r="http://schemas.openxmlformats.org/officeDocument/2006/relationships" xmlns:p="http://schemas.openxmlformats.org/presentationml/2006/main">
   <p:cSld>
     <p:spTree>
       <p:nvGrpSpPr>
@@ -3095,7 +3090,14 @@
         <p:cNvGrpSpPr/>
         <p:nvPr/>
       </p:nvGrpSpPr>
-      <p:grpSpPr/>
+      <p:grpSpPr>
+        <a:xfrm>
+          <a:off x="0" y="0"/>
+          <a:ext cx="0" cy="0"/>
+          <a:chOff x="0" y="0"/>
+          <a:chExt cx="0" cy="0"/>
+        </a:xfrm>
+      </p:grpSpPr>
       <p:pic>
         <p:nvPicPr>
           <p:cNvPr id="2" name="Picture 1" descr="prismatic_bg.jpg"/>
@@ -3227,10 +3229,14 @@
               </a:defRPr>
             </a:pPr>
             <a:r>
+              <a:rPr dirty="0"/>
               <a:t>Automated Action Item, Assignee &amp; Deadline Extraction</a:t>
             </a:r>
-            <a:br/>
-            <a:r>
+            <a:br>
+              <a:rPr dirty="0"/>
+            </a:br>
+            <a:r>
+              <a:rPr dirty="0"/>
               <a:t>Powered by Retrieval-Augmented Generation &amp; Intelligent LLMs</a:t>
             </a:r>
           </a:p>
@@ -3245,7 +3251,7 @@
         <p:spPr>
           <a:xfrm>
             <a:off x="914400" y="5760720"/>
-            <a:ext cx="6858000" cy="457200"/>
+            <a:ext cx="5376793" cy="261610"/>
           </a:xfrm>
           <a:prstGeom prst="rect">
             <a:avLst/>
@@ -3267,7 +3273,20 @@
               </a:defRPr>
             </a:pPr>
             <a:r>
-              <a:t>Presented by Keshav | Department of Computer Science &amp; Engineering</a:t>
+              <a:rPr dirty="0"/>
+              <a:t>Presented by </a:t>
+            </a:r>
+            <a:r>
+              <a:rPr lang="en-US" dirty="0" err="1"/>
+              <a:t>Darshveer</a:t>
+            </a:r>
+            <a:r>
+              <a:rPr lang="en-US" dirty="0"/>
+              <a:t> &amp; </a:t>
+            </a:r>
+            <a:r>
+              <a:rPr dirty="0"/>
+              <a:t>Keshav | Department of Computer Science &amp; Engineering</a:t>
             </a:r>
           </a:p>
         </p:txBody>
@@ -3281,7 +3300,7 @@
 </file>
 
 <file path=ppt/slides/slide2.xml><?xml version="1.0" encoding="utf-8"?>
-<p:sld xmlns:a="http://schemas.openxmlformats.org/drawingml/2006/main" xmlns:p="http://schemas.openxmlformats.org/presentationml/2006/main" xmlns:r="http://schemas.openxmlformats.org/officeDocument/2006/relationships">
+<p:sld xmlns:a="http://schemas.openxmlformats.org/drawingml/2006/main" xmlns:r="http://schemas.openxmlformats.org/officeDocument/2006/relationships" xmlns:p="http://schemas.openxmlformats.org/presentationml/2006/main">
   <p:cSld>
     <p:spTree>
       <p:nvGrpSpPr>
@@ -3289,7 +3308,14 @@
         <p:cNvGrpSpPr/>
         <p:nvPr/>
       </p:nvGrpSpPr>
-      <p:grpSpPr/>
+      <p:grpSpPr>
+        <a:xfrm>
+          <a:off x="0" y="0"/>
+          <a:ext cx="0" cy="0"/>
+          <a:chOff x="0" y="0"/>
+          <a:chExt cx="0" cy="0"/>
+        </a:xfrm>
+      </p:grpSpPr>
       <p:sp>
         <p:nvSpPr>
           <p:cNvPr id="2" name="Rectangle 1"/>
@@ -3330,6 +3356,7 @@
           <a:lstStyle/>
           <a:p>
             <a:pPr algn="ctr"/>
+            <a:endParaRPr/>
           </a:p>
         </p:txBody>
       </p:sp>
@@ -3443,7 +3470,7 @@
           </a:fontRef>
         </p:style>
         <p:txBody>
-          <a:bodyPr rtlCol="0" anchor="ctr" wrap="square" lIns="320040" tIns="320040" rIns="320040" bIns="320040"/>
+          <a:bodyPr wrap="square" lIns="320040" tIns="320040" rIns="320040" bIns="320040" rtlCol="0" anchor="ctr"/>
           <a:lstStyle/>
           <a:p>
             <a:pPr algn="ctr">
@@ -3562,7 +3589,7 @@
           </a:fontRef>
         </p:style>
         <p:txBody>
-          <a:bodyPr rtlCol="0" anchor="ctr" wrap="square" lIns="182880" tIns="182880" rIns="182880" bIns="182880"/>
+          <a:bodyPr wrap="square" lIns="182880" tIns="182880" rIns="182880" bIns="182880" rtlCol="0" anchor="ctr"/>
           <a:lstStyle/>
           <a:p>
             <a:pPr algn="ctr">
@@ -3633,7 +3660,7 @@
           </a:fontRef>
         </p:style>
         <p:txBody>
-          <a:bodyPr rtlCol="0" anchor="ctr" wrap="square" lIns="182880" tIns="182880" rIns="182880" bIns="182880"/>
+          <a:bodyPr wrap="square" lIns="182880" tIns="182880" rIns="182880" bIns="182880" rtlCol="0" anchor="ctr"/>
           <a:lstStyle/>
           <a:p>
             <a:pPr algn="ctr">
@@ -3704,7 +3731,7 @@
           </a:fontRef>
         </p:style>
         <p:txBody>
-          <a:bodyPr rtlCol="0" anchor="ctr" wrap="square" lIns="182880" tIns="182880" rIns="182880" bIns="182880"/>
+          <a:bodyPr wrap="square" lIns="182880" tIns="182880" rIns="182880" bIns="182880" rtlCol="0" anchor="ctr"/>
           <a:lstStyle/>
           <a:p>
             <a:pPr algn="ctr">
@@ -3746,7 +3773,7 @@
 </file>
 
 <file path=ppt/slides/slide3.xml><?xml version="1.0" encoding="utf-8"?>
-<p:sld xmlns:a="http://schemas.openxmlformats.org/drawingml/2006/main" xmlns:p="http://schemas.openxmlformats.org/presentationml/2006/main" xmlns:r="http://schemas.openxmlformats.org/officeDocument/2006/relationships">
+<p:sld xmlns:a="http://schemas.openxmlformats.org/drawingml/2006/main" xmlns:r="http://schemas.openxmlformats.org/officeDocument/2006/relationships" xmlns:p="http://schemas.openxmlformats.org/presentationml/2006/main">
   <p:cSld>
     <p:spTree>
       <p:nvGrpSpPr>
@@ -3754,7 +3781,14 @@
         <p:cNvGrpSpPr/>
         <p:nvPr/>
       </p:nvGrpSpPr>
-      <p:grpSpPr/>
+      <p:grpSpPr>
+        <a:xfrm>
+          <a:off x="0" y="0"/>
+          <a:ext cx="0" cy="0"/>
+          <a:chOff x="0" y="0"/>
+          <a:chExt cx="0" cy="0"/>
+        </a:xfrm>
+      </p:grpSpPr>
       <p:sp>
         <p:nvSpPr>
           <p:cNvPr id="2" name="Rectangle 1"/>
@@ -3795,6 +3829,7 @@
           <a:lstStyle/>
           <a:p>
             <a:pPr algn="ctr"/>
+            <a:endParaRPr/>
           </a:p>
         </p:txBody>
       </p:sp>
@@ -3908,7 +3943,7 @@
           </a:fontRef>
         </p:style>
         <p:txBody>
-          <a:bodyPr rtlCol="0" anchor="ctr" wrap="square" lIns="228600" tIns="228600" rIns="228600" bIns="228600"/>
+          <a:bodyPr wrap="square" lIns="228600" tIns="228600" rIns="228600" bIns="228600" rtlCol="0" anchor="ctr"/>
           <a:lstStyle/>
           <a:p>
             <a:pPr algn="ctr">
@@ -3979,7 +4014,7 @@
           </a:fontRef>
         </p:style>
         <p:txBody>
-          <a:bodyPr rtlCol="0" anchor="ctr" wrap="square" lIns="228600" tIns="228600" rIns="228600" bIns="228600"/>
+          <a:bodyPr wrap="square" lIns="228600" tIns="228600" rIns="228600" bIns="228600" rtlCol="0" anchor="ctr"/>
           <a:lstStyle/>
           <a:p>
             <a:pPr algn="ctr">
@@ -4050,7 +4085,7 @@
           </a:fontRef>
         </p:style>
         <p:txBody>
-          <a:bodyPr rtlCol="0" anchor="ctr" wrap="square" lIns="228600" tIns="228600" rIns="228600" bIns="228600"/>
+          <a:bodyPr wrap="square" lIns="228600" tIns="228600" rIns="228600" bIns="228600" rtlCol="0" anchor="ctr"/>
           <a:lstStyle/>
           <a:p>
             <a:pPr algn="ctr">
@@ -4121,7 +4156,7 @@
           </a:fontRef>
         </p:style>
         <p:txBody>
-          <a:bodyPr rtlCol="0" anchor="ctr" wrap="square" lIns="228600" tIns="228600" rIns="228600" bIns="228600"/>
+          <a:bodyPr wrap="square" lIns="228600" tIns="228600" rIns="228600" bIns="228600" rtlCol="0" anchor="ctr"/>
           <a:lstStyle/>
           <a:p>
             <a:pPr algn="ctr">
@@ -4163,7 +4198,7 @@
 </file>
 
 <file path=ppt/slides/slide4.xml><?xml version="1.0" encoding="utf-8"?>
-<p:sld xmlns:a="http://schemas.openxmlformats.org/drawingml/2006/main" xmlns:p="http://schemas.openxmlformats.org/presentationml/2006/main" xmlns:r="http://schemas.openxmlformats.org/officeDocument/2006/relationships">
+<p:sld xmlns:a="http://schemas.openxmlformats.org/drawingml/2006/main" xmlns:r="http://schemas.openxmlformats.org/officeDocument/2006/relationships" xmlns:p="http://schemas.openxmlformats.org/presentationml/2006/main">
   <p:cSld>
     <p:spTree>
       <p:nvGrpSpPr>
@@ -4171,7 +4206,14 @@
         <p:cNvGrpSpPr/>
         <p:nvPr/>
       </p:nvGrpSpPr>
-      <p:grpSpPr/>
+      <p:grpSpPr>
+        <a:xfrm>
+          <a:off x="0" y="0"/>
+          <a:ext cx="0" cy="0"/>
+          <a:chOff x="0" y="0"/>
+          <a:chExt cx="0" cy="0"/>
+        </a:xfrm>
+      </p:grpSpPr>
       <p:sp>
         <p:nvSpPr>
           <p:cNvPr id="2" name="Rectangle 1"/>
@@ -4212,6 +4254,7 @@
           <a:lstStyle/>
           <a:p>
             <a:pPr algn="ctr"/>
+            <a:endParaRPr/>
           </a:p>
         </p:txBody>
       </p:sp>
@@ -4325,7 +4368,7 @@
           </a:fontRef>
         </p:style>
         <p:txBody>
-          <a:bodyPr rtlCol="0" anchor="ctr" wrap="square" lIns="182880" tIns="182880" rIns="182880" bIns="182880"/>
+          <a:bodyPr wrap="square" lIns="182880" tIns="182880" rIns="182880" bIns="182880" rtlCol="0" anchor="ctr"/>
           <a:lstStyle/>
           <a:p>
             <a:pPr algn="ctr">
@@ -4412,7 +4455,7 @@
           </a:fontRef>
         </p:style>
         <p:txBody>
-          <a:bodyPr rtlCol="0" anchor="ctr" wrap="square" lIns="182880" tIns="182880" rIns="182880" bIns="182880"/>
+          <a:bodyPr wrap="square" lIns="182880" tIns="182880" rIns="182880" bIns="182880" rtlCol="0" anchor="ctr"/>
           <a:lstStyle/>
           <a:p>
             <a:pPr algn="ctr">
@@ -4499,7 +4542,7 @@
           </a:fontRef>
         </p:style>
         <p:txBody>
-          <a:bodyPr rtlCol="0" anchor="ctr" wrap="square" lIns="182880" tIns="182880" rIns="182880" bIns="182880"/>
+          <a:bodyPr wrap="square" lIns="182880" tIns="182880" rIns="182880" bIns="182880" rtlCol="0" anchor="ctr"/>
           <a:lstStyle/>
           <a:p>
             <a:pPr algn="ctr">
@@ -4586,7 +4629,7 @@
           </a:fontRef>
         </p:style>
         <p:txBody>
-          <a:bodyPr rtlCol="0" anchor="ctr" wrap="square" lIns="182880" tIns="182880" rIns="182880" bIns="182880"/>
+          <a:bodyPr wrap="square" lIns="182880" tIns="182880" rIns="182880" bIns="182880" rtlCol="0" anchor="ctr"/>
           <a:lstStyle/>
           <a:p>
             <a:pPr algn="ctr">
@@ -4673,7 +4716,7 @@
           </a:fontRef>
         </p:style>
         <p:txBody>
-          <a:bodyPr rtlCol="0" anchor="ctr" wrap="square" lIns="182880" tIns="182880" rIns="182880" bIns="182880"/>
+          <a:bodyPr wrap="square" lIns="182880" tIns="182880" rIns="182880" bIns="182880" rtlCol="0" anchor="ctr"/>
           <a:lstStyle/>
           <a:p>
             <a:pPr algn="ctr">
@@ -4760,7 +4803,7 @@
           </a:fontRef>
         </p:style>
         <p:txBody>
-          <a:bodyPr rtlCol="0" anchor="ctr" wrap="square" lIns="182880" tIns="182880" rIns="182880" bIns="182880"/>
+          <a:bodyPr wrap="square" lIns="182880" tIns="182880" rIns="182880" bIns="182880" rtlCol="0" anchor="ctr"/>
           <a:lstStyle/>
           <a:p>
             <a:pPr algn="ctr">
@@ -4818,7 +4861,7 @@
 </file>
 
 <file path=ppt/slides/slide5.xml><?xml version="1.0" encoding="utf-8"?>
-<p:sld xmlns:a="http://schemas.openxmlformats.org/drawingml/2006/main" xmlns:p="http://schemas.openxmlformats.org/presentationml/2006/main" xmlns:r="http://schemas.openxmlformats.org/officeDocument/2006/relationships">
+<p:sld xmlns:a="http://schemas.openxmlformats.org/drawingml/2006/main" xmlns:r="http://schemas.openxmlformats.org/officeDocument/2006/relationships" xmlns:p="http://schemas.openxmlformats.org/presentationml/2006/main">
   <p:cSld>
     <p:spTree>
       <p:nvGrpSpPr>
@@ -4826,7 +4869,14 @@
         <p:cNvGrpSpPr/>
         <p:nvPr/>
       </p:nvGrpSpPr>
-      <p:grpSpPr/>
+      <p:grpSpPr>
+        <a:xfrm>
+          <a:off x="0" y="0"/>
+          <a:ext cx="0" cy="0"/>
+          <a:chOff x="0" y="0"/>
+          <a:chExt cx="0" cy="0"/>
+        </a:xfrm>
+      </p:grpSpPr>
       <p:sp>
         <p:nvSpPr>
           <p:cNvPr id="2" name="Rectangle 1"/>
@@ -4867,6 +4917,7 @@
           <a:lstStyle/>
           <a:p>
             <a:pPr algn="ctr"/>
+            <a:endParaRPr/>
           </a:p>
         </p:txBody>
       </p:sp>
@@ -4980,7 +5031,7 @@
           </a:fontRef>
         </p:style>
         <p:txBody>
-          <a:bodyPr rtlCol="0" anchor="ctr" wrap="square" lIns="320040" tIns="320040" rIns="320040" bIns="320040"/>
+          <a:bodyPr wrap="square" lIns="320040" tIns="320040" rIns="320040" bIns="320040" rtlCol="0" anchor="ctr"/>
           <a:lstStyle/>
           <a:p>
             <a:pPr algn="ctr">
@@ -5099,7 +5150,7 @@
           </a:fontRef>
         </p:style>
         <p:txBody>
-          <a:bodyPr rtlCol="0" anchor="ctr" wrap="square" lIns="320040" tIns="320040" rIns="320040" bIns="320040"/>
+          <a:bodyPr wrap="square" lIns="320040" tIns="320040" rIns="320040" bIns="320040" rtlCol="0" anchor="ctr"/>
           <a:lstStyle/>
           <a:p>
             <a:pPr algn="ctr">
@@ -5189,7 +5240,7 @@
 </file>
 
 <file path=ppt/slides/slide6.xml><?xml version="1.0" encoding="utf-8"?>
-<p:sld xmlns:a="http://schemas.openxmlformats.org/drawingml/2006/main" xmlns:p="http://schemas.openxmlformats.org/presentationml/2006/main" xmlns:r="http://schemas.openxmlformats.org/officeDocument/2006/relationships">
+<p:sld xmlns:a="http://schemas.openxmlformats.org/drawingml/2006/main" xmlns:r="http://schemas.openxmlformats.org/officeDocument/2006/relationships" xmlns:p="http://schemas.openxmlformats.org/presentationml/2006/main">
   <p:cSld>
     <p:spTree>
       <p:nvGrpSpPr>
@@ -5197,7 +5248,14 @@
         <p:cNvGrpSpPr/>
         <p:nvPr/>
       </p:nvGrpSpPr>
-      <p:grpSpPr/>
+      <p:grpSpPr>
+        <a:xfrm>
+          <a:off x="0" y="0"/>
+          <a:ext cx="0" cy="0"/>
+          <a:chOff x="0" y="0"/>
+          <a:chExt cx="0" cy="0"/>
+        </a:xfrm>
+      </p:grpSpPr>
       <p:sp>
         <p:nvSpPr>
           <p:cNvPr id="2" name="Rectangle 1"/>
@@ -5238,6 +5296,7 @@
           <a:lstStyle/>
           <a:p>
             <a:pPr algn="ctr"/>
+            <a:endParaRPr/>
           </a:p>
         </p:txBody>
       </p:sp>
@@ -5375,7 +5434,7 @@
           </a:fontRef>
         </p:style>
         <p:txBody>
-          <a:bodyPr rtlCol="0" anchor="ctr" wrap="square" lIns="274320" tIns="274320" rIns="274320" bIns="274320"/>
+          <a:bodyPr wrap="square" lIns="274320" tIns="274320" rIns="274320" bIns="274320" rtlCol="0" anchor="ctr"/>
           <a:lstStyle/>
           <a:p>
             <a:pPr algn="ctr">
@@ -5465,7 +5524,7 @@
 </file>
 
 <file path=ppt/slides/slide7.xml><?xml version="1.0" encoding="utf-8"?>
-<p:sld xmlns:a="http://schemas.openxmlformats.org/drawingml/2006/main" xmlns:p="http://schemas.openxmlformats.org/presentationml/2006/main" xmlns:r="http://schemas.openxmlformats.org/officeDocument/2006/relationships">
+<p:sld xmlns:a="http://schemas.openxmlformats.org/drawingml/2006/main" xmlns:r="http://schemas.openxmlformats.org/officeDocument/2006/relationships" xmlns:p="http://schemas.openxmlformats.org/presentationml/2006/main">
   <p:cSld>
     <p:spTree>
       <p:nvGrpSpPr>
@@ -5473,7 +5532,14 @@
         <p:cNvGrpSpPr/>
         <p:nvPr/>
       </p:nvGrpSpPr>
-      <p:grpSpPr/>
+      <p:grpSpPr>
+        <a:xfrm>
+          <a:off x="0" y="0"/>
+          <a:ext cx="0" cy="0"/>
+          <a:chOff x="0" y="0"/>
+          <a:chExt cx="0" cy="0"/>
+        </a:xfrm>
+      </p:grpSpPr>
       <p:sp>
         <p:nvSpPr>
           <p:cNvPr id="2" name="Rectangle 1"/>
@@ -5514,6 +5580,7 @@
           <a:lstStyle/>
           <a:p>
             <a:pPr algn="ctr"/>
+            <a:endParaRPr/>
           </a:p>
         </p:txBody>
       </p:sp>
@@ -5651,7 +5718,7 @@
           </a:fontRef>
         </p:style>
         <p:txBody>
-          <a:bodyPr rtlCol="0" anchor="ctr" wrap="square" lIns="274320" tIns="274320" rIns="274320" bIns="274320"/>
+          <a:bodyPr wrap="square" lIns="274320" tIns="274320" rIns="274320" bIns="274320" rtlCol="0" anchor="ctr"/>
           <a:lstStyle/>
           <a:p>
             <a:pPr algn="ctr">
@@ -5757,7 +5824,7 @@
 </file>
 
 <file path=ppt/slides/slide8.xml><?xml version="1.0" encoding="utf-8"?>
-<p:sld xmlns:a="http://schemas.openxmlformats.org/drawingml/2006/main" xmlns:p="http://schemas.openxmlformats.org/presentationml/2006/main" xmlns:r="http://schemas.openxmlformats.org/officeDocument/2006/relationships">
+<p:sld xmlns:a="http://schemas.openxmlformats.org/drawingml/2006/main" xmlns:r="http://schemas.openxmlformats.org/officeDocument/2006/relationships" xmlns:p="http://schemas.openxmlformats.org/presentationml/2006/main">
   <p:cSld>
     <p:spTree>
       <p:nvGrpSpPr>
@@ -5765,7 +5832,14 @@
         <p:cNvGrpSpPr/>
         <p:nvPr/>
       </p:nvGrpSpPr>
-      <p:grpSpPr/>
+      <p:grpSpPr>
+        <a:xfrm>
+          <a:off x="0" y="0"/>
+          <a:ext cx="0" cy="0"/>
+          <a:chOff x="0" y="0"/>
+          <a:chExt cx="0" cy="0"/>
+        </a:xfrm>
+      </p:grpSpPr>
       <p:sp>
         <p:nvSpPr>
           <p:cNvPr id="2" name="Rectangle 1"/>
@@ -5806,6 +5880,7 @@
           <a:lstStyle/>
           <a:p>
             <a:pPr algn="ctr"/>
+            <a:endParaRPr/>
           </a:p>
         </p:txBody>
       </p:sp>
@@ -5919,7 +5994,7 @@
           </a:fontRef>
         </p:style>
         <p:txBody>
-          <a:bodyPr rtlCol="0" anchor="ctr" wrap="square" lIns="182880" tIns="182880" rIns="182880" bIns="182880"/>
+          <a:bodyPr wrap="square" lIns="182880" tIns="182880" rIns="182880" bIns="182880" rtlCol="0" anchor="ctr"/>
           <a:lstStyle/>
           <a:p>
             <a:pPr algn="ctr">
@@ -6006,7 +6081,7 @@
           </a:fontRef>
         </p:style>
         <p:txBody>
-          <a:bodyPr rtlCol="0" anchor="ctr" wrap="square" lIns="182880" tIns="182880" rIns="182880" bIns="182880"/>
+          <a:bodyPr wrap="square" lIns="182880" tIns="182880" rIns="182880" bIns="182880" rtlCol="0" anchor="ctr"/>
           <a:lstStyle/>
           <a:p>
             <a:pPr algn="ctr">
@@ -6093,7 +6168,7 @@
           </a:fontRef>
         </p:style>
         <p:txBody>
-          <a:bodyPr rtlCol="0" anchor="ctr" wrap="square" lIns="182880" tIns="182880" rIns="182880" bIns="182880"/>
+          <a:bodyPr wrap="square" lIns="182880" tIns="182880" rIns="182880" bIns="182880" rtlCol="0" anchor="ctr"/>
           <a:lstStyle/>
           <a:p>
             <a:pPr algn="ctr">
@@ -6180,7 +6255,7 @@
           </a:fontRef>
         </p:style>
         <p:txBody>
-          <a:bodyPr rtlCol="0" anchor="ctr" wrap="square" lIns="182880" tIns="182880" rIns="182880" bIns="182880"/>
+          <a:bodyPr wrap="square" lIns="182880" tIns="182880" rIns="182880" bIns="182880" rtlCol="0" anchor="ctr"/>
           <a:lstStyle/>
           <a:p>
             <a:pPr algn="ctr">
@@ -6267,7 +6342,7 @@
           </a:fontRef>
         </p:style>
         <p:txBody>
-          <a:bodyPr rtlCol="0" anchor="ctr" wrap="square" lIns="182880" tIns="182880" rIns="182880" bIns="182880"/>
+          <a:bodyPr wrap="square" lIns="182880" tIns="182880" rIns="182880" bIns="182880" rtlCol="0" anchor="ctr"/>
           <a:lstStyle/>
           <a:p>
             <a:pPr algn="ctr">
@@ -6354,7 +6429,7 @@
           </a:fontRef>
         </p:style>
         <p:txBody>
-          <a:bodyPr rtlCol="0" anchor="ctr" wrap="square" lIns="182880" tIns="182880" rIns="182880" bIns="182880"/>
+          <a:bodyPr wrap="square" lIns="182880" tIns="182880" rIns="182880" bIns="182880" rtlCol="0" anchor="ctr"/>
           <a:lstStyle/>
           <a:p>
             <a:pPr algn="ctr">
@@ -6412,7 +6487,7 @@
 </file>
 
 <file path=ppt/slides/slide9.xml><?xml version="1.0" encoding="utf-8"?>
-<p:sld xmlns:a="http://schemas.openxmlformats.org/drawingml/2006/main" xmlns:p="http://schemas.openxmlformats.org/presentationml/2006/main" xmlns:r="http://schemas.openxmlformats.org/officeDocument/2006/relationships">
+<p:sld xmlns:a="http://schemas.openxmlformats.org/drawingml/2006/main" xmlns:r="http://schemas.openxmlformats.org/officeDocument/2006/relationships" xmlns:p="http://schemas.openxmlformats.org/presentationml/2006/main">
   <p:cSld>
     <p:spTree>
       <p:nvGrpSpPr>
@@ -6420,7 +6495,14 @@
         <p:cNvGrpSpPr/>
         <p:nvPr/>
       </p:nvGrpSpPr>
-      <p:grpSpPr/>
+      <p:grpSpPr>
+        <a:xfrm>
+          <a:off x="0" y="0"/>
+          <a:ext cx="0" cy="0"/>
+          <a:chOff x="0" y="0"/>
+          <a:chExt cx="0" cy="0"/>
+        </a:xfrm>
+      </p:grpSpPr>
       <p:pic>
         <p:nvPicPr>
           <p:cNvPr id="2" name="Picture 1" descr="prismatic_bg.jpg"/>
@@ -6483,7 +6565,7 @@
           </a:fontRef>
         </p:style>
         <p:txBody>
-          <a:bodyPr rtlCol="0" anchor="ctr" wrap="square" lIns="365760" tIns="365760" rIns="365760" bIns="365760"/>
+          <a:bodyPr wrap="square" lIns="365760" tIns="365760" rIns="365760" bIns="365760" rtlCol="0" anchor="ctr"/>
           <a:lstStyle/>
           <a:p>
             <a:pPr algn="ctr">

</xml_diff>